<commit_message>
Update pricing to 40/60 revenue split, fix Shane's name
- Replace design partner CTA with clear 40%/60% split breakdown
- Rename Sahen to Shane Fuller
- Regenerate PPTX to match

Co-Authored-By: Claude Opus 4.6 <noreply@anthropic.com>
</commit_message>
<xml_diff>
--- a/public/Source-AI-Pitch-Deck.pptx
+++ b/public/Source-AI-Pitch-Deck.pptx
@@ -9253,7 +9253,7 @@
               </a:defRPr>
             </a:pPr>
             <a:r>
-              <a:t>First migration free. After that, pricing is negotiated as a revenue share. No subscriptions, no per-seat fees.</a:t>
+              <a:t>Source takes 40% of the project fee — built into the price your client pays. You keep 60% with zero delivery cost.</a:t>
             </a:r>
           </a:p>
         </p:txBody>
@@ -10520,7 +10520,7 @@
               </a:defRPr>
             </a:pPr>
             <a:r>
-              <a:t>$0</a:t>
+              <a:t>40%</a:t>
             </a:r>
           </a:p>
         </p:txBody>
@@ -10556,7 +10556,7 @@
               </a:defRPr>
             </a:pPr>
             <a:r>
-              <a:t>FIRST MIGRATION</a:t>
+              <a:t>SOURCE AI FEE</a:t>
             </a:r>
           </a:p>
         </p:txBody>
@@ -10569,8 +10569,80 @@
         </p:nvSpPr>
         <p:spPr>
           <a:xfrm>
-            <a:off x="4114800" y="7040880"/>
-            <a:ext cx="6400800" cy="365760"/>
+            <a:off x="3840480" y="6949440"/>
+            <a:ext cx="1828800" cy="640080"/>
+          </a:xfrm>
+          <a:prstGeom prst="rect">
+            <a:avLst/>
+          </a:prstGeom>
+          <a:noFill/>
+        </p:spPr>
+        <p:txBody>
+          <a:bodyPr wrap="square">
+            <a:spAutoFit/>
+          </a:bodyPr>
+          <a:lstStyle/>
+          <a:p>
+            <a:pPr algn="l">
+              <a:defRPr sz="4000" b="1" i="0">
+                <a:solidFill>
+                  <a:srgbClr val="FFFFFF"/>
+                </a:solidFill>
+                <a:latin typeface="Arial"/>
+              </a:defRPr>
+            </a:pPr>
+            <a:r>
+              <a:t>60%</a:t>
+            </a:r>
+          </a:p>
+        </p:txBody>
+      </p:sp>
+      <p:sp>
+        <p:nvSpPr>
+          <p:cNvPr id="40" name="TextBox 39"/>
+          <p:cNvSpPr txBox="1"/>
+          <p:nvPr/>
+        </p:nvSpPr>
+        <p:spPr>
+          <a:xfrm>
+            <a:off x="3840480" y="7635240"/>
+            <a:ext cx="1828800" cy="274320"/>
+          </a:xfrm>
+          <a:prstGeom prst="rect">
+            <a:avLst/>
+          </a:prstGeom>
+          <a:noFill/>
+        </p:spPr>
+        <p:txBody>
+          <a:bodyPr wrap="square">
+            <a:spAutoFit/>
+          </a:bodyPr>
+          <a:lstStyle/>
+          <a:p>
+            <a:pPr algn="l">
+              <a:defRPr sz="900" b="0" i="0">
+                <a:solidFill>
+                  <a:srgbClr val="787878"/>
+                </a:solidFill>
+                <a:latin typeface="Courier New"/>
+              </a:defRPr>
+            </a:pPr>
+            <a:r>
+              <a:t>YOU KEEP</a:t>
+            </a:r>
+          </a:p>
+        </p:txBody>
+      </p:sp>
+      <p:sp>
+        <p:nvSpPr>
+          <p:cNvPr id="41" name="TextBox 40"/>
+          <p:cNvSpPr txBox="1"/>
+          <p:nvPr/>
+        </p:nvSpPr>
+        <p:spPr>
+          <a:xfrm>
+            <a:off x="6400800" y="7040880"/>
+            <a:ext cx="5943600" cy="365760"/>
           </a:xfrm>
           <a:prstGeom prst="rect">
             <a:avLst/>
@@ -10592,21 +10664,21 @@
               </a:defRPr>
             </a:pPr>
             <a:r>
-              <a:t>We're looking for design partners.</a:t>
-            </a:r>
-          </a:p>
-        </p:txBody>
-      </p:sp>
-      <p:sp>
-        <p:nvSpPr>
-          <p:cNvPr id="40" name="TextBox 39"/>
-          <p:cNvSpPr txBox="1"/>
-          <p:nvPr/>
-        </p:nvSpPr>
-        <p:spPr>
-          <a:xfrm>
-            <a:off x="4114800" y="7498080"/>
-            <a:ext cx="6400800" cy="548640"/>
+              <a:t>Built into the price.</a:t>
+            </a:r>
+          </a:p>
+        </p:txBody>
+      </p:sp>
+      <p:sp>
+        <p:nvSpPr>
+          <p:cNvPr id="42" name="TextBox 41"/>
+          <p:cNvSpPr txBox="1"/>
+          <p:nvPr/>
+        </p:nvSpPr>
+        <p:spPr>
+          <a:xfrm>
+            <a:off x="6400800" y="7498080"/>
+            <a:ext cx="5943600" cy="548640"/>
           </a:xfrm>
           <a:prstGeom prst="rect">
             <a:avLst/>
@@ -10628,7 +10700,7 @@
               </a:defRPr>
             </a:pPr>
             <a:r>
-              <a:t>Your first migration is completely free — see the full output before any commitment.</a:t>
+              <a:t>Source’s 40% is included in the project fee your client pays. You keep 60% with zero delivery overhead.</a:t>
             </a:r>
           </a:p>
         </p:txBody>
@@ -11416,7 +11488,7 @@
               </a:defRPr>
             </a:pPr>
             <a:r>
-              <a:t>Sahen Fuller</a:t>
+              <a:t>Shane Fuller</a:t>
             </a:r>
           </a:p>
         </p:txBody>

</xml_diff>

<commit_message>
Update pitch deck: refine copy, pricing, and workflow steps
- Remove presentation hint UI bar (keep keyboard/click navigation)
- Update workflow steps: rename labels, reorder BRD Draft before AI Questionnaire
- Change "Sub 21" to "Under 21 days" / "21 day migrations"
- Make migration path arrows bidirectional, remove "100s more" pills
- Bold black text in Solution subtitle, unbold grey text
- Redesign pricing black bar with FREE + before/after comparison
- Enlarge integration bar text and spacing

Made-with: Cursor
</commit_message>
<xml_diff>
--- a/public/Source-AI-Pitch-Deck.pptx
+++ b/public/Source-AI-Pitch-Deck.pptx
@@ -6,15 +6,6 @@
   </p:sldMasterIdLst>
   <p:sldIdLst>
     <p:sldId id="256" r:id="rId7"/>
-    <p:sldId id="257" r:id="rId8"/>
-    <p:sldId id="258" r:id="rId9"/>
-    <p:sldId id="259" r:id="rId10"/>
-    <p:sldId id="260" r:id="rId11"/>
-    <p:sldId id="261" r:id="rId12"/>
-    <p:sldId id="262" r:id="rId13"/>
-    <p:sldId id="263" r:id="rId14"/>
-    <p:sldId id="264" r:id="rId15"/>
-    <p:sldId id="265" r:id="rId16"/>
   </p:sldIdLst>
   <p:sldSz cx="14630400" cy="8229600" type="screen4x3"/>
   <p:notesSz cx="6858000" cy="9144000"/>
@@ -3100,384 +3091,6 @@
       <p:pic>
         <p:nvPicPr>
           <p:cNvPr id="2" name="Picture 1" descr="slide-00.png"/>
-          <p:cNvPicPr>
-            <a:picLocks noChangeAspect="1"/>
-          </p:cNvPicPr>
-          <p:nvPr/>
-        </p:nvPicPr>
-        <p:blipFill>
-          <a:blip r:embed="rId2"/>
-          <a:stretch>
-            <a:fillRect/>
-          </a:stretch>
-        </p:blipFill>
-        <p:spPr>
-          <a:xfrm>
-            <a:off x="0" y="0"/>
-            <a:ext cx="14630400" cy="8229600"/>
-          </a:xfrm>
-          <a:prstGeom prst="rect">
-            <a:avLst/>
-          </a:prstGeom>
-        </p:spPr>
-      </p:pic>
-    </p:spTree>
-  </p:cSld>
-  <p:clrMapOvr>
-    <a:masterClrMapping/>
-  </p:clrMapOvr>
-</p:sld>
-</file>
-
-<file path=ppt/slides/slide10.xml><?xml version="1.0" encoding="utf-8"?>
-<p:sld xmlns:a="http://schemas.openxmlformats.org/drawingml/2006/main" xmlns:p="http://schemas.openxmlformats.org/presentationml/2006/main" xmlns:r="http://schemas.openxmlformats.org/officeDocument/2006/relationships">
-  <p:cSld>
-    <p:spTree>
-      <p:nvGrpSpPr>
-        <p:cNvPr id="1" name=""/>
-        <p:cNvGrpSpPr/>
-        <p:nvPr/>
-      </p:nvGrpSpPr>
-      <p:grpSpPr/>
-      <p:pic>
-        <p:nvPicPr>
-          <p:cNvPr id="2" name="Picture 1" descr="slide-09.png"/>
-          <p:cNvPicPr>
-            <a:picLocks noChangeAspect="1"/>
-          </p:cNvPicPr>
-          <p:nvPr/>
-        </p:nvPicPr>
-        <p:blipFill>
-          <a:blip r:embed="rId2"/>
-          <a:stretch>
-            <a:fillRect/>
-          </a:stretch>
-        </p:blipFill>
-        <p:spPr>
-          <a:xfrm>
-            <a:off x="0" y="0"/>
-            <a:ext cx="14630400" cy="8229600"/>
-          </a:xfrm>
-          <a:prstGeom prst="rect">
-            <a:avLst/>
-          </a:prstGeom>
-        </p:spPr>
-      </p:pic>
-    </p:spTree>
-  </p:cSld>
-  <p:clrMapOvr>
-    <a:masterClrMapping/>
-  </p:clrMapOvr>
-</p:sld>
-</file>
-
-<file path=ppt/slides/slide2.xml><?xml version="1.0" encoding="utf-8"?>
-<p:sld xmlns:a="http://schemas.openxmlformats.org/drawingml/2006/main" xmlns:p="http://schemas.openxmlformats.org/presentationml/2006/main" xmlns:r="http://schemas.openxmlformats.org/officeDocument/2006/relationships">
-  <p:cSld>
-    <p:spTree>
-      <p:nvGrpSpPr>
-        <p:cNvPr id="1" name=""/>
-        <p:cNvGrpSpPr/>
-        <p:nvPr/>
-      </p:nvGrpSpPr>
-      <p:grpSpPr/>
-      <p:pic>
-        <p:nvPicPr>
-          <p:cNvPr id="2" name="Picture 1" descr="slide-01.png"/>
-          <p:cNvPicPr>
-            <a:picLocks noChangeAspect="1"/>
-          </p:cNvPicPr>
-          <p:nvPr/>
-        </p:nvPicPr>
-        <p:blipFill>
-          <a:blip r:embed="rId2"/>
-          <a:stretch>
-            <a:fillRect/>
-          </a:stretch>
-        </p:blipFill>
-        <p:spPr>
-          <a:xfrm>
-            <a:off x="0" y="0"/>
-            <a:ext cx="14630400" cy="8229600"/>
-          </a:xfrm>
-          <a:prstGeom prst="rect">
-            <a:avLst/>
-          </a:prstGeom>
-        </p:spPr>
-      </p:pic>
-    </p:spTree>
-  </p:cSld>
-  <p:clrMapOvr>
-    <a:masterClrMapping/>
-  </p:clrMapOvr>
-</p:sld>
-</file>
-
-<file path=ppt/slides/slide3.xml><?xml version="1.0" encoding="utf-8"?>
-<p:sld xmlns:a="http://schemas.openxmlformats.org/drawingml/2006/main" xmlns:p="http://schemas.openxmlformats.org/presentationml/2006/main" xmlns:r="http://schemas.openxmlformats.org/officeDocument/2006/relationships">
-  <p:cSld>
-    <p:spTree>
-      <p:nvGrpSpPr>
-        <p:cNvPr id="1" name=""/>
-        <p:cNvGrpSpPr/>
-        <p:nvPr/>
-      </p:nvGrpSpPr>
-      <p:grpSpPr/>
-      <p:pic>
-        <p:nvPicPr>
-          <p:cNvPr id="2" name="Picture 1" descr="slide-02.png"/>
-          <p:cNvPicPr>
-            <a:picLocks noChangeAspect="1"/>
-          </p:cNvPicPr>
-          <p:nvPr/>
-        </p:nvPicPr>
-        <p:blipFill>
-          <a:blip r:embed="rId2"/>
-          <a:stretch>
-            <a:fillRect/>
-          </a:stretch>
-        </p:blipFill>
-        <p:spPr>
-          <a:xfrm>
-            <a:off x="0" y="0"/>
-            <a:ext cx="14630400" cy="8229600"/>
-          </a:xfrm>
-          <a:prstGeom prst="rect">
-            <a:avLst/>
-          </a:prstGeom>
-        </p:spPr>
-      </p:pic>
-    </p:spTree>
-  </p:cSld>
-  <p:clrMapOvr>
-    <a:masterClrMapping/>
-  </p:clrMapOvr>
-</p:sld>
-</file>
-
-<file path=ppt/slides/slide4.xml><?xml version="1.0" encoding="utf-8"?>
-<p:sld xmlns:a="http://schemas.openxmlformats.org/drawingml/2006/main" xmlns:p="http://schemas.openxmlformats.org/presentationml/2006/main" xmlns:r="http://schemas.openxmlformats.org/officeDocument/2006/relationships">
-  <p:cSld>
-    <p:spTree>
-      <p:nvGrpSpPr>
-        <p:cNvPr id="1" name=""/>
-        <p:cNvGrpSpPr/>
-        <p:nvPr/>
-      </p:nvGrpSpPr>
-      <p:grpSpPr/>
-      <p:pic>
-        <p:nvPicPr>
-          <p:cNvPr id="2" name="Picture 1" descr="slide-03.png"/>
-          <p:cNvPicPr>
-            <a:picLocks noChangeAspect="1"/>
-          </p:cNvPicPr>
-          <p:nvPr/>
-        </p:nvPicPr>
-        <p:blipFill>
-          <a:blip r:embed="rId2"/>
-          <a:stretch>
-            <a:fillRect/>
-          </a:stretch>
-        </p:blipFill>
-        <p:spPr>
-          <a:xfrm>
-            <a:off x="0" y="0"/>
-            <a:ext cx="14630400" cy="8229600"/>
-          </a:xfrm>
-          <a:prstGeom prst="rect">
-            <a:avLst/>
-          </a:prstGeom>
-        </p:spPr>
-      </p:pic>
-    </p:spTree>
-  </p:cSld>
-  <p:clrMapOvr>
-    <a:masterClrMapping/>
-  </p:clrMapOvr>
-</p:sld>
-</file>
-
-<file path=ppt/slides/slide5.xml><?xml version="1.0" encoding="utf-8"?>
-<p:sld xmlns:a="http://schemas.openxmlformats.org/drawingml/2006/main" xmlns:p="http://schemas.openxmlformats.org/presentationml/2006/main" xmlns:r="http://schemas.openxmlformats.org/officeDocument/2006/relationships">
-  <p:cSld>
-    <p:spTree>
-      <p:nvGrpSpPr>
-        <p:cNvPr id="1" name=""/>
-        <p:cNvGrpSpPr/>
-        <p:nvPr/>
-      </p:nvGrpSpPr>
-      <p:grpSpPr/>
-      <p:pic>
-        <p:nvPicPr>
-          <p:cNvPr id="2" name="Picture 1" descr="slide-04.png"/>
-          <p:cNvPicPr>
-            <a:picLocks noChangeAspect="1"/>
-          </p:cNvPicPr>
-          <p:nvPr/>
-        </p:nvPicPr>
-        <p:blipFill>
-          <a:blip r:embed="rId2"/>
-          <a:stretch>
-            <a:fillRect/>
-          </a:stretch>
-        </p:blipFill>
-        <p:spPr>
-          <a:xfrm>
-            <a:off x="0" y="0"/>
-            <a:ext cx="14630400" cy="8229600"/>
-          </a:xfrm>
-          <a:prstGeom prst="rect">
-            <a:avLst/>
-          </a:prstGeom>
-        </p:spPr>
-      </p:pic>
-    </p:spTree>
-  </p:cSld>
-  <p:clrMapOvr>
-    <a:masterClrMapping/>
-  </p:clrMapOvr>
-</p:sld>
-</file>
-
-<file path=ppt/slides/slide6.xml><?xml version="1.0" encoding="utf-8"?>
-<p:sld xmlns:a="http://schemas.openxmlformats.org/drawingml/2006/main" xmlns:p="http://schemas.openxmlformats.org/presentationml/2006/main" xmlns:r="http://schemas.openxmlformats.org/officeDocument/2006/relationships">
-  <p:cSld>
-    <p:spTree>
-      <p:nvGrpSpPr>
-        <p:cNvPr id="1" name=""/>
-        <p:cNvGrpSpPr/>
-        <p:nvPr/>
-      </p:nvGrpSpPr>
-      <p:grpSpPr/>
-      <p:pic>
-        <p:nvPicPr>
-          <p:cNvPr id="2" name="Picture 1" descr="slide-05.png"/>
-          <p:cNvPicPr>
-            <a:picLocks noChangeAspect="1"/>
-          </p:cNvPicPr>
-          <p:nvPr/>
-        </p:nvPicPr>
-        <p:blipFill>
-          <a:blip r:embed="rId2"/>
-          <a:stretch>
-            <a:fillRect/>
-          </a:stretch>
-        </p:blipFill>
-        <p:spPr>
-          <a:xfrm>
-            <a:off x="0" y="0"/>
-            <a:ext cx="14630400" cy="8229600"/>
-          </a:xfrm>
-          <a:prstGeom prst="rect">
-            <a:avLst/>
-          </a:prstGeom>
-        </p:spPr>
-      </p:pic>
-    </p:spTree>
-  </p:cSld>
-  <p:clrMapOvr>
-    <a:masterClrMapping/>
-  </p:clrMapOvr>
-</p:sld>
-</file>
-
-<file path=ppt/slides/slide7.xml><?xml version="1.0" encoding="utf-8"?>
-<p:sld xmlns:a="http://schemas.openxmlformats.org/drawingml/2006/main" xmlns:p="http://schemas.openxmlformats.org/presentationml/2006/main" xmlns:r="http://schemas.openxmlformats.org/officeDocument/2006/relationships">
-  <p:cSld>
-    <p:spTree>
-      <p:nvGrpSpPr>
-        <p:cNvPr id="1" name=""/>
-        <p:cNvGrpSpPr/>
-        <p:nvPr/>
-      </p:nvGrpSpPr>
-      <p:grpSpPr/>
-      <p:pic>
-        <p:nvPicPr>
-          <p:cNvPr id="2" name="Picture 1" descr="slide-06.png"/>
-          <p:cNvPicPr>
-            <a:picLocks noChangeAspect="1"/>
-          </p:cNvPicPr>
-          <p:nvPr/>
-        </p:nvPicPr>
-        <p:blipFill>
-          <a:blip r:embed="rId2"/>
-          <a:stretch>
-            <a:fillRect/>
-          </a:stretch>
-        </p:blipFill>
-        <p:spPr>
-          <a:xfrm>
-            <a:off x="0" y="0"/>
-            <a:ext cx="14630400" cy="8229600"/>
-          </a:xfrm>
-          <a:prstGeom prst="rect">
-            <a:avLst/>
-          </a:prstGeom>
-        </p:spPr>
-      </p:pic>
-    </p:spTree>
-  </p:cSld>
-  <p:clrMapOvr>
-    <a:masterClrMapping/>
-  </p:clrMapOvr>
-</p:sld>
-</file>
-
-<file path=ppt/slides/slide8.xml><?xml version="1.0" encoding="utf-8"?>
-<p:sld xmlns:a="http://schemas.openxmlformats.org/drawingml/2006/main" xmlns:p="http://schemas.openxmlformats.org/presentationml/2006/main" xmlns:r="http://schemas.openxmlformats.org/officeDocument/2006/relationships">
-  <p:cSld>
-    <p:spTree>
-      <p:nvGrpSpPr>
-        <p:cNvPr id="1" name=""/>
-        <p:cNvGrpSpPr/>
-        <p:nvPr/>
-      </p:nvGrpSpPr>
-      <p:grpSpPr/>
-      <p:pic>
-        <p:nvPicPr>
-          <p:cNvPr id="2" name="Picture 1" descr="slide-07.png"/>
-          <p:cNvPicPr>
-            <a:picLocks noChangeAspect="1"/>
-          </p:cNvPicPr>
-          <p:nvPr/>
-        </p:nvPicPr>
-        <p:blipFill>
-          <a:blip r:embed="rId2"/>
-          <a:stretch>
-            <a:fillRect/>
-          </a:stretch>
-        </p:blipFill>
-        <p:spPr>
-          <a:xfrm>
-            <a:off x="0" y="0"/>
-            <a:ext cx="14630400" cy="8229600"/>
-          </a:xfrm>
-          <a:prstGeom prst="rect">
-            <a:avLst/>
-          </a:prstGeom>
-        </p:spPr>
-      </p:pic>
-    </p:spTree>
-  </p:cSld>
-  <p:clrMapOvr>
-    <a:masterClrMapping/>
-  </p:clrMapOvr>
-</p:sld>
-</file>
-
-<file path=ppt/slides/slide9.xml><?xml version="1.0" encoding="utf-8"?>
-<p:sld xmlns:a="http://schemas.openxmlformats.org/drawingml/2006/main" xmlns:p="http://schemas.openxmlformats.org/presentationml/2006/main" xmlns:r="http://schemas.openxmlformats.org/officeDocument/2006/relationships">
-  <p:cSld>
-    <p:spTree>
-      <p:nvGrpSpPr>
-        <p:cNvPr id="1" name=""/>
-        <p:cNvGrpSpPr/>
-        <p:nvPr/>
-      </p:nvGrpSpPr>
-      <p:grpSpPr/>
-      <p:pic>
-        <p:nvPicPr>
-          <p:cNvPr id="2" name="Picture 1" descr="slide-08.png"/>
           <p:cNvPicPr>
             <a:picLocks noChangeAspect="1"/>
           </p:cNvPicPr>

</xml_diff>